<commit_message>
Level 5 Lesson 7 draft listening audio (1:30)
</commit_message>
<xml_diff>
--- a/level5/slides/Level5_Lesson7_Slides.pptx
+++ b/level5/slides/Level5_Lesson7_Slides.pptx
@@ -8,32 +8,32 @@
     <p:notesMasterId r:id="rId22"/>
   </p:notesMasterIdLst>
   <p:sldIdLst>
-    <p:sldId id="939" r:id="rId33"/>
-    <p:sldId id="940" r:id="rId34"/>
-    <p:sldId id="941" r:id="rId35"/>
-    <p:sldId id="942" r:id="rId36"/>
-    <p:sldId id="943" r:id="rId31"/>
-    <p:sldId id="944" r:id="rId30"/>
-    <p:sldId id="945" r:id="rId29"/>
-    <p:sldId id="946" r:id="rId28"/>
-    <p:sldId id="947" r:id="rId27"/>
-    <p:sldId id="948" r:id="rId20"/>
-    <p:sldId id="949" r:id="rId18"/>
-    <p:sldId id="950" r:id="rId17"/>
-    <p:sldId id="951" r:id="rId16"/>
-    <p:sldId id="952" r:id="rId14"/>
-    <p:sldId id="953" r:id="rId13"/>
-    <p:sldId id="954" r:id="rId12"/>
-    <p:sldId id="955" r:id="rId11"/>
-    <p:sldId id="956" r:id="rId10"/>
-    <p:sldId id="957" r:id="rId8"/>
-    <p:sldId id="958" r:id="rId7"/>
-    <p:sldId id="959" r:id="rId6"/>
-    <p:sldId id="960" r:id="rId5"/>
-    <p:sldId id="961" r:id="rId4"/>
-    <p:sldId id="962" r:id="rId3"/>
-    <p:sldId id="963" r:id="rId57"/>
-    <p:sldId id="964" r:id="rId2"/>
+    <p:sldId id="965" r:id="rId32"/>
+    <p:sldId id="966" r:id="rId21"/>
+    <p:sldId id="967" r:id="rId19"/>
+    <p:sldId id="968" r:id="rId15"/>
+    <p:sldId id="969" r:id="rId37"/>
+    <p:sldId id="970" r:id="rId38"/>
+    <p:sldId id="971" r:id="rId39"/>
+    <p:sldId id="972" r:id="rId40"/>
+    <p:sldId id="973" r:id="rId41"/>
+    <p:sldId id="974" r:id="rId42"/>
+    <p:sldId id="975" r:id="rId43"/>
+    <p:sldId id="976" r:id="rId44"/>
+    <p:sldId id="977" r:id="rId45"/>
+    <p:sldId id="978" r:id="rId46"/>
+    <p:sldId id="979" r:id="rId47"/>
+    <p:sldId id="980" r:id="rId48"/>
+    <p:sldId id="981" r:id="rId49"/>
+    <p:sldId id="982" r:id="rId50"/>
+    <p:sldId id="983" r:id="rId51"/>
+    <p:sldId id="984" r:id="rId52"/>
+    <p:sldId id="985" r:id="rId53"/>
+    <p:sldId id="986" r:id="rId54"/>
+    <p:sldId id="987" r:id="rId55"/>
+    <p:sldId id="988" r:id="rId56"/>
+    <p:sldId id="989" r:id="rId9"/>
+    <p:sldId id="990" r:id="rId58"/>
   </p:sldIdLst>
   <p:sldSz cx="12192000" cy="6858000"/>
   <p:notesSz cx="6858000" cy="12192000"/>
@@ -481,7 +481,7 @@
 </p:notesMaster>
 </file>
 
-<file path=ppt/notesSlides/notesSlide1.xml><?xml version="1.0" encoding="utf-8"?>
+<file path=ppt/notesSlides/notesSlide14.xml><?xml version="1.0" encoding="utf-8"?>
 <p:notes xmlns:a="http://schemas.openxmlformats.org/drawingml/2006/main" xmlns:p="http://schemas.openxmlformats.org/presentationml/2006/main" xmlns:r="http://schemas.openxmlformats.org/officeDocument/2006/relationships">
   <p:cSld>
     <p:spTree>
@@ -526,27 +526,17 @@
           <a:lstStyle/>
           <a:p>
             <a:r>
-              <a:t>Credits. You don't need to read this slide in class.</a:t>
-            </a:r>
-          </a:p>
-          <a:p>
-            <a:r>
-              <a:t>Pictures: Twemoji graphics by Twitter, Inc. and other contributors, CC BY 4.0; the file-by-file list is in images/CREDITS.md.</a:t>
-            </a:r>
-          </a:p>
-          <a:p>
-            <a:r>
-              <a:t>Audio: the listening audio for this lesson (about 2:10) is coming soon. It will use computer-generated voices (Chatterbox TTS cloned from synthetic Kokoro-82M reference clips); no recordings of real people. Until it is ready, read the listening script (in the notes of the Before You Listen slide) with a volunteer. The names and the story are invented.</a:t>
-            </a:r>
-          </a:p>
-          <a:p>
-            <a:r>
-              <a:t>Course materials: © 2026 the authors, licensed under CC BY-NC-SA 4.0 (https://creativecommons.org/licenses/by-nc-sa/4.0/).</a:t>
-            </a:r>
-          </a:p>
-          <a:p>
-            <a:r>
-              <a:t>Lesson plan: Picture Credits. Picture list: images/CREDITS.md.</a:t>
+              <a:t>Each click shows the next card.</a:t>
+            </a:r>
+          </a:p>
+          <a:p>
+            <a:r>
+              <a:t>A asks. B answers. Then switch.</a:t>
+            </a:r>
+          </a:p>
+          <a:p>
+            <a:r>
+              <a:t>Lesson plan: Step 1; Opening Talk page.</a:t>
             </a:r>
           </a:p>
         </p:txBody>
@@ -571,7 +561,7 @@
 </p:notes>
 </file>
 
-<file path=ppt/notesSlides/notesSlide10.xml><?xml version="1.0" encoding="utf-8"?>
+<file path=ppt/notesSlides/notesSlide18.xml><?xml version="1.0" encoding="utf-8"?>
 <p:notes xmlns:a="http://schemas.openxmlformats.org/drawingml/2006/main" xmlns:p="http://schemas.openxmlformats.org/presentationml/2006/main" xmlns:r="http://schemas.openxmlformats.org/officeDocument/2006/relationships">
   <p:cSld>
     <p:spTree>
@@ -616,12 +606,22 @@
           <a:lstStyle/>
           <a:p>
             <a:r>
-              <a:t>Click to show each answer: 1 didn't you • 2 isn't it • 3 is she • 4 don't you • 5 doesn't it • 6 didn't she</a:t>
-            </a:r>
-          </a:p>
-          <a:p>
-            <a:r>
-              <a:t>Lesson plan: Step 4; Grammar Practice A; Answer key.</a:t>
+              <a:t>Step 1 · 6:00–6:06 · Opening Talk.</a:t>
+            </a:r>
+          </a:p>
+          <a:p>
+            <a:r>
+              <a:t>Work with a partner.</a:t>
+            </a:r>
+          </a:p>
+          <a:p>
+            <a:r>
+              <a:t>Lesson plan: Step 1; Opening Talk page.</a:t>
+            </a:r>
+          </a:p>
+          <a:p>
+            <a:r>
+              <a:t>Picture: Twemoji graphics by Twitter, Inc. and other contributors (https://github.com/jdecked/twemoji), CC BY 4.0 (https://creativecommons.org/licenses/by/4.0/); resized and combined, with signs and labels (images/CREDITS.md).</a:t>
             </a:r>
           </a:p>
         </p:txBody>
@@ -646,7 +646,7 @@
 </p:notes>
 </file>
 
-<file path=ppt/notesSlides/notesSlide11.xml><?xml version="1.0" encoding="utf-8"?>
+<file path=ppt/notesSlides/notesSlide20.xml><?xml version="1.0" encoding="utf-8"?>
 <p:notes xmlns:a="http://schemas.openxmlformats.org/drawingml/2006/main" xmlns:p="http://schemas.openxmlformats.org/presentationml/2006/main" xmlns:r="http://schemas.openxmlformats.org/officeDocument/2006/relationships">
   <p:cSld>
     <p:spTree>
@@ -691,17 +691,12 @@
           <a:lstStyle/>
           <a:p>
             <a:r>
-              <a:t>Grammar Box 4: correct a detail. Each click shows the answer side.</a:t>
-            </a:r>
-          </a:p>
-          <a:p>
-            <a:r>
-              <a:t>Lesson plan: Step 4; Grammar Box 4.</a:t>
-            </a:r>
-          </a:p>
-          <a:p>
-            <a:r>
-              <a:t>Picture: Twemoji graphics by Twitter, Inc. and other contributors (https://github.com/jdecked/twemoji), CC BY 4.0 (https://creativecommons.org/licenses/by/4.0/); resized and combined, with signs and labels (images/CREDITS.md).</a:t>
+              <a:t>Read each goal slowly. Learners repeat.</a:t>
+            </a:r>
+          </a:p>
+          <a:p>
+            <a:r>
+              <a:t>Lesson plan: At a glance: Objectives.</a:t>
             </a:r>
           </a:p>
         </p:txBody>
@@ -726,7 +721,7 @@
 </p:notes>
 </file>
 
-<file path=ppt/notesSlides/notesSlide12.xml><?xml version="1.0" encoding="utf-8"?>
+<file path=ppt/notesSlides/notesSlide26.xml><?xml version="1.0" encoding="utf-8"?>
 <p:notes xmlns:a="http://schemas.openxmlformats.org/drawingml/2006/main" xmlns:p="http://schemas.openxmlformats.org/presentationml/2006/main" xmlns:r="http://schemas.openxmlformats.org/officeDocument/2006/relationships">
   <p:cSld>
     <p:spTree>
@@ -771,12 +766,22 @@
           <a:lstStyle/>
           <a:p>
             <a:r>
-              <a:t>Grammar Box 3: do, does, or did. Each click shows the answer side.</a:t>
-            </a:r>
-          </a:p>
-          <a:p>
-            <a:r>
-              <a:t>Lesson plan: Step 4; Grammar Box 3.</a:t>
+              <a:t>Welcome learners as they arrive.</a:t>
+            </a:r>
+          </a:p>
+          <a:p>
+            <a:r>
+              <a:t>Read the three lines under Today you will.</a:t>
+            </a:r>
+          </a:p>
+          <a:p>
+            <a:r>
+              <a:t>Do not collect real Social Security numbers, immigration papers, bank numbers, or medical record numbers.</a:t>
+            </a:r>
+          </a:p>
+          <a:p>
+            <a:r>
+              <a:t>Lesson plan: Topic; At a glance: Objectives.</a:t>
             </a:r>
           </a:p>
           <a:p>
@@ -806,7 +811,7 @@
 </p:notes>
 </file>
 
-<file path=ppt/notesSlides/notesSlide13.xml><?xml version="1.0" encoding="utf-8"?>
+<file path=ppt/notesSlides/notesSlide31.xml><?xml version="1.0" encoding="utf-8"?>
 <p:notes xmlns:a="http://schemas.openxmlformats.org/drawingml/2006/main" xmlns:p="http://schemas.openxmlformats.org/presentationml/2006/main" xmlns:r="http://schemas.openxmlformats.org/officeDocument/2006/relationships">
   <p:cSld>
     <p:spTree>
@@ -851,17 +856,22 @@
           <a:lstStyle/>
           <a:p>
             <a:r>
-              <a:t>Grammar Box 2: a positive tag. Each click shows the answer side.</a:t>
-            </a:r>
-          </a:p>
-          <a:p>
-            <a:r>
-              <a:t>Lesson plan: Step 4; Grammar Box 2.</a:t>
-            </a:r>
-          </a:p>
-          <a:p>
-            <a:r>
-              <a:t>Picture: Twemoji graphics by Twitter, Inc. and other contributors (https://github.com/jdecked/twemoji), CC BY 4.0 (https://creativecommons.org/licenses/by/4.0/); resized and combined, with signs and labels (images/CREDITS.md).</a:t>
+              <a:t>Step 2 · 6:06–6:12 · New Words.</a:t>
+            </a:r>
+          </a:p>
+          <a:p>
+            <a:r>
+              <a:t>Point to each picture. Learners repeat. ★ = most important.</a:t>
+            </a:r>
+          </a:p>
+          <a:p>
+            <a:r>
+              <a:t>Lesson plan: Step 2; New Words page.</a:t>
+            </a:r>
+          </a:p>
+          <a:p>
+            <a:r>
+              <a:t>Pictures: Twemoji graphics by Twitter, Inc. and other contributors (https://github.com/jdecked/twemoji), CC BY 4.0 (https://creativecommons.org/licenses/by/4.0/); resized and combined, with signs and labels (images/CREDITS.md).</a:t>
             </a:r>
           </a:p>
         </p:txBody>
@@ -886,7 +896,7 @@
 </p:notes>
 </file>
 
-<file path=ppt/notesSlides/notesSlide15.xml><?xml version="1.0" encoding="utf-8"?>
+<file path=ppt/notesSlides/notesSlide32.xml><?xml version="1.0" encoding="utf-8"?>
 <p:notes xmlns:a="http://schemas.openxmlformats.org/drawingml/2006/main" xmlns:p="http://schemas.openxmlformats.org/presentationml/2006/main" xmlns:r="http://schemas.openxmlformats.org/officeDocument/2006/relationships">
   <p:cSld>
     <p:spTree>
@@ -931,17 +941,17 @@
           <a:lstStyle/>
           <a:p>
             <a:r>
-              <a:t>Grammar Box 1: a negative tag. Each click shows the answer side.</a:t>
-            </a:r>
-          </a:p>
-          <a:p>
-            <a:r>
-              <a:t>Lesson plan: Step 4; Grammar Box 1.</a:t>
-            </a:r>
-          </a:p>
-          <a:p>
-            <a:r>
-              <a:t>Picture: Twemoji graphics by Twitter, Inc. and other contributors (https://github.com/jdecked/twemoji), CC BY 4.0 (https://creativecommons.org/licenses/by/4.0/); resized and combined, with signs and labels (images/CREDITS.md).</a:t>
+              <a:t>A points to a picture. B names it and uses it in one sentence. Then switch.</a:t>
+            </a:r>
+          </a:p>
+          <a:p>
+            <a:r>
+              <a:t>Lesson plan: Step 2; New Words page; Partner game.</a:t>
+            </a:r>
+          </a:p>
+          <a:p>
+            <a:r>
+              <a:t>Pictures: Twemoji graphics by Twitter, Inc. and other contributors (https://github.com/jdecked/twemoji), CC BY 4.0 (https://creativecommons.org/licenses/by/4.0/); resized and combined, with signs and labels (images/CREDITS.md).</a:t>
             </a:r>
           </a:p>
         </p:txBody>
@@ -966,7 +976,7 @@
 </p:notes>
 </file>
 
-<file path=ppt/notesSlides/notesSlide16.xml><?xml version="1.0" encoding="utf-8"?>
+<file path=ppt/notesSlides/notesSlide33.xml><?xml version="1.0" encoding="utf-8"?>
 <p:notes xmlns:a="http://schemas.openxmlformats.org/drawingml/2006/main" xmlns:p="http://schemas.openxmlformats.org/presentationml/2006/main" xmlns:r="http://schemas.openxmlformats.org/officeDocument/2006/relationships">
   <p:cSld>
     <p:spTree>
@@ -1011,12 +1021,32 @@
           <a:lstStyle/>
           <a:p>
             <a:r>
-              <a:t>gonna and wanna are short forms. This listening uses the full forms. Say each line two times.</a:t>
-            </a:r>
-          </a:p>
-          <a:p>
-            <a:r>
-              <a:t>Lesson plan: Step 3: Hear it, say it.</a:t>
+              <a:t>The answers are hidden. Ask, then click.</a:t>
+            </a:r>
+          </a:p>
+          <a:p>
+            <a:r>
+              <a:t>1. an email address</a:t>
+            </a:r>
+          </a:p>
+          <a:p>
+            <a:r>
+              <a:t>2. a checkbox</a:t>
+            </a:r>
+          </a:p>
+          <a:p>
+            <a:r>
+              <a:t>3. capital</a:t>
+            </a:r>
+          </a:p>
+          <a:p>
+            <a:r>
+              <a:t>Lesson plan: Step 2: Check the Meaning.</a:t>
+            </a:r>
+          </a:p>
+          <a:p>
+            <a:r>
+              <a:t>Pictures: Twemoji graphics by Twitter, Inc. and other contributors (https://github.com/jdecked/twemoji), CC BY 4.0 (https://creativecommons.org/licenses/by/4.0/); resized and combined, with signs and labels (images/CREDITS.md).</a:t>
             </a:r>
           </a:p>
         </p:txBody>
@@ -1041,7 +1071,7 @@
 </p:notes>
 </file>
 
-<file path=ppt/notesSlides/notesSlide17.xml><?xml version="1.0" encoding="utf-8"?>
+<file path=ppt/notesSlides/notesSlide34.xml><?xml version="1.0" encoding="utf-8"?>
 <p:notes xmlns:a="http://schemas.openxmlformats.org/drawingml/2006/main" xmlns:p="http://schemas.openxmlformats.org/presentationml/2006/main" xmlns:r="http://schemas.openxmlformats.org/officeDocument/2006/relationships">
   <p:cSld>
     <p:spTree>
@@ -1086,12 +1116,27 @@
           <a:lstStyle/>
           <a:p>
             <a:r>
-              <a:t>Click to show each answer: 1 didn't you • 2 isn't it • 3 isn't it • 4 didn't you • 5 isn't it • 6 is she</a:t>
-            </a:r>
-          </a:p>
-          <a:p>
-            <a:r>
-              <a:t>Lesson plan: Step 3; Listening Task C; Answer key.</a:t>
+              <a:t>Step 3 · 6:12–6:32 · Listening. Play 1 is Task A. Play 2 is Tasks B and C. A third play is fine.</a:t>
+            </a:r>
+          </a:p>
+          <a:p>
+            <a:r>
+              <a:t>Leah is at a community center desk.</a:t>
+            </a:r>
+          </a:p>
+          <a:p>
+            <a:r>
+              <a:t>The script says going to and want to. Learners only need to recognize gonna and wanna.</a:t>
+            </a:r>
+          </a:p>
+          <a:p>
+            <a:r>
+              <a:t>Lesson plan: Step 3; Listening page.</a:t>
+            </a:r>
+          </a:p>
+          <a:p>
+            <a:r>
+              <a:t>Picture: Twemoji graphics by Twitter, Inc. and other contributors (https://github.com/jdecked/twemoji), CC BY 4.0 (https://creativecommons.org/licenses/by/4.0/); resized and combined, with signs and labels (images/CREDITS.md).</a:t>
             </a:r>
           </a:p>
         </p:txBody>
@@ -1116,7 +1161,7 @@
 </p:notes>
 </file>
 
-<file path=ppt/notesSlides/notesSlide19.xml><?xml version="1.0" encoding="utf-8"?>
+<file path=ppt/notesSlides/notesSlide35.xml><?xml version="1.0" encoding="utf-8"?>
 <p:notes xmlns:a="http://schemas.openxmlformats.org/drawingml/2006/main" xmlns:p="http://schemas.openxmlformats.org/presentationml/2006/main" xmlns:r="http://schemas.openxmlformats.org/officeDocument/2006/relationships">
   <p:cSld>
     <p:spTree>
@@ -1161,12 +1206,12 @@
           <a:lstStyle/>
           <a:p>
             <a:r>
-              <a:t>Click to circle each answer: 1 Correct • 2 Correct • 3 Correct • 4 Correct • 5 Wrong. C forty-two is class ID C-42. Tuesday at six is 6:00. The room on his copy is A; the schedule says room C</a:t>
-            </a:r>
-          </a:p>
-          <a:p>
-            <a:r>
-              <a:t>Lesson plan: Step 3; Listening Task B; Answer key.</a:t>
+              <a:t>Click to circle b.</a:t>
+            </a:r>
+          </a:p>
+          <a:p>
+            <a:r>
+              <a:t>Lesson plan: Step 3; Listening Task A; Answer key.</a:t>
             </a:r>
           </a:p>
         </p:txBody>
@@ -1191,7 +1236,7 @@
 </p:notes>
 </file>
 
-<file path=ppt/notesSlides/notesSlide2.xml><?xml version="1.0" encoding="utf-8"?>
+<file path=ppt/notesSlides/notesSlide36.xml><?xml version="1.0" encoding="utf-8"?>
 <p:notes xmlns:a="http://schemas.openxmlformats.org/drawingml/2006/main" xmlns:p="http://schemas.openxmlformats.org/presentationml/2006/main" xmlns:r="http://schemas.openxmlformats.org/officeDocument/2006/relationships">
   <p:cSld>
     <p:spTree>
@@ -1236,22 +1281,12 @@
           <a:lstStyle/>
           <a:p>
             <a:r>
-              <a:t>Step 7 · 7:25–7:30 · Exit ticket and homework. Never skip the exit ticket.</a:t>
-            </a:r>
-          </a:p>
-          <a:p>
-            <a:r>
-              <a:t>Confirm two details about this class.</a:t>
-            </a:r>
-          </a:p>
-          <a:p>
-            <a:r>
-              <a:t>Lesson plan: Step 7; Exit Ticket page; Homework page.</a:t>
-            </a:r>
-          </a:p>
-          <a:p>
-            <a:r>
-              <a:t>Picture: Twemoji graphics by Twitter, Inc. and other contributors (https://github.com/jdecked/twemoji), CC BY 4.0 (https://creativecommons.org/licenses/by/4.0/); resized and combined, with signs and labels (images/CREDITS.md).</a:t>
+              <a:t>Click to circle each answer: 1 Correct • 2 Correct • 3 Correct • 4 Correct • 5 Wrong. C forty-two is class ID C-42. Tuesday at six is 6:00. The room on his copy is A; the schedule says room C</a:t>
+            </a:r>
+          </a:p>
+          <a:p>
+            <a:r>
+              <a:t>Lesson plan: Step 3; Listening Task B; Answer key.</a:t>
             </a:r>
           </a:p>
         </p:txBody>
@@ -1276,7 +1311,7 @@
 </p:notes>
 </file>
 
-<file path=ppt/notesSlides/notesSlide21.xml><?xml version="1.0" encoding="utf-8"?>
+<file path=ppt/notesSlides/notesSlide37.xml><?xml version="1.0" encoding="utf-8"?>
 <p:notes xmlns:a="http://schemas.openxmlformats.org/drawingml/2006/main" xmlns:p="http://schemas.openxmlformats.org/presentationml/2006/main" xmlns:r="http://schemas.openxmlformats.org/officeDocument/2006/relationships">
   <p:cSld>
     <p:spTree>
@@ -1321,12 +1356,12 @@
           <a:lstStyle/>
           <a:p>
             <a:r>
-              <a:t>Click to circle b.</a:t>
-            </a:r>
-          </a:p>
-          <a:p>
-            <a:r>
-              <a:t>Lesson plan: Step 3; Listening Task A; Answer key.</a:t>
+              <a:t>Click to show each answer: 1 didn't you • 2 isn't it • 3 isn't it • 4 didn't you • 5 isn't it • 6 is she</a:t>
+            </a:r>
+          </a:p>
+          <a:p>
+            <a:r>
+              <a:t>Lesson plan: Step 3; Listening Task C; Answer key.</a:t>
             </a:r>
           </a:p>
         </p:txBody>
@@ -1351,7 +1386,7 @@
 </p:notes>
 </file>
 
-<file path=ppt/notesSlides/notesSlide22.xml><?xml version="1.0" encoding="utf-8"?>
+<file path=ppt/notesSlides/notesSlide38.xml><?xml version="1.0" encoding="utf-8"?>
 <p:notes xmlns:a="http://schemas.openxmlformats.org/drawingml/2006/main" xmlns:p="http://schemas.openxmlformats.org/presentationml/2006/main" xmlns:r="http://schemas.openxmlformats.org/officeDocument/2006/relationships">
   <p:cSld>
     <p:spTree>
@@ -1396,132 +1431,12 @@
           <a:lstStyle/>
           <a:p>
             <a:r>
-              <a:t>Step 3 · 6:12–6:32 · Listening. Play 1 is Task A. Play 2 is Tasks B and C. A third play is fine.</a:t>
-            </a:r>
-          </a:p>
-          <a:p>
-            <a:r>
-              <a:t>Leah is at a community center desk.</a:t>
-            </a:r>
-          </a:p>
-          <a:p>
-            <a:r>
-              <a:t>The script says going to and want to. Learners only need to recognize gonna and wanna.</a:t>
-            </a:r>
-          </a:p>
-          <a:p>
-            <a:r>
-              <a:t>Lesson plan: Step 3; Listening page.</a:t>
-            </a:r>
-          </a:p>
-          <a:p>
-            <a:r>
-              <a:t>Picture: Twemoji graphics by Twitter, Inc. and other contributors (https://github.com/jdecked/twemoji), CC BY 4.0 (https://creativecommons.org/licenses/by/4.0/); resized and combined, with signs and labels (images/CREDITS.md).</a:t>
-            </a:r>
-          </a:p>
-          <a:p>
-            <a:r>
-              <a:t>Listening script (the audio is coming soon; until then, read it aloud with a volunteer at a normal, friendly speed):</a:t>
-            </a:r>
-          </a:p>
-          <a:p>
-            <a:r>
-              <a:t>Narrator: Lesson seven. Leah is at the community center desk. She wants to check her evening-class form. Mr. Ortiz has the copy.</a:t>
-            </a:r>
-          </a:p>
-          <a:p>
-            <a:r>
-              <a:t>Mr. Ortiz: Good evening. You sent the form, didn't you?</a:t>
-            </a:r>
-          </a:p>
-          <a:p>
-            <a:r>
-              <a:t>Leah: Yes, I did. I want to double-check every line.</a:t>
-            </a:r>
-          </a:p>
-          <a:p>
-            <a:r>
-              <a:t>Mr. Ortiz: Your class ID is C forty-two, isn't it?</a:t>
-            </a:r>
-          </a:p>
-          <a:p>
-            <a:r>
-              <a:t>Leah: Yes, it is.</a:t>
-            </a:r>
-          </a:p>
-          <a:p>
-            <a:r>
-              <a:t>Mr. Ortiz: And the email address is leah at mail dot example, isn't it?</a:t>
-            </a:r>
-          </a:p>
-          <a:p>
-            <a:r>
-              <a:t>Leah: Yes, it is. The L in Leah is a capital letter. Please check the spelling.</a:t>
-            </a:r>
-          </a:p>
-          <a:p>
-            <a:r>
-              <a:t>Mr. Ortiz: I will. You wrote a phone number on line three, didn't you?</a:t>
-            </a:r>
-          </a:p>
-          <a:p>
-            <a:r>
-              <a:t>Leah: Yes, I did. I double-checked it at home.</a:t>
-            </a:r>
-          </a:p>
-          <a:p>
-            <a:r>
-              <a:t>Mr. Ortiz: The class is on Tuesday at six, isn't it?</a:t>
-            </a:r>
-          </a:p>
-          <a:p>
-            <a:r>
-              <a:t>Leah: Yes, it is. I'm going to come straight from work.</a:t>
-            </a:r>
-          </a:p>
-          <a:p>
-            <a:r>
-              <a:t>Mr. Ortiz: And the room is A, isn't it?</a:t>
-            </a:r>
-          </a:p>
-          <a:p>
-            <a:r>
-              <a:t>Leah: Actually, it isn't. The schedule says room C. Can you make that correction?</a:t>
-            </a:r>
-          </a:p>
-          <a:p>
-            <a:r>
-              <a:t>Mr. Ortiz: You're right. I'll change the room to C and initial the correction.</a:t>
-            </a:r>
-          </a:p>
-          <a:p>
-            <a:r>
-              <a:t>Leah: Thank you. My signature is on the form, isn't it?</a:t>
-            </a:r>
-          </a:p>
-          <a:p>
-            <a:r>
-              <a:t>Mr. Ortiz: Yes, it is. I'll check the box and give you this copy.</a:t>
-            </a:r>
-          </a:p>
-          <a:p>
-            <a:r>
-              <a:t>Leah: Great. I'm going to keep the copy.</a:t>
-            </a:r>
-          </a:p>
-          <a:p>
-            <a:r>
-              <a:t>Mr. Ortiz: Your friend isn't in this class, is she?</a:t>
-            </a:r>
-          </a:p>
-          <a:p>
-            <a:r>
-              <a:t>Leah: No, she isn't. This copy is only for me.</a:t>
-            </a:r>
-          </a:p>
-          <a:p>
-            <a:r>
-              <a:t>Narrator: That's the end of the listening.</a:t>
+              <a:t>gonna and wanna are short forms. This listening uses the full forms. Say each line two times.</a:t>
+            </a:r>
+          </a:p>
+          <a:p>
+            <a:r>
+              <a:t>Lesson plan: Step 3: Hear it, say it.</a:t>
             </a:r>
           </a:p>
         </p:txBody>
@@ -1546,7 +1461,7 @@
 </p:notes>
 </file>
 
-<file path=ppt/notesSlides/notesSlide23.xml><?xml version="1.0" encoding="utf-8"?>
+<file path=ppt/notesSlides/notesSlide39.xml><?xml version="1.0" encoding="utf-8"?>
 <p:notes xmlns:a="http://schemas.openxmlformats.org/drawingml/2006/main" xmlns:p="http://schemas.openxmlformats.org/presentationml/2006/main" xmlns:r="http://schemas.openxmlformats.org/officeDocument/2006/relationships">
   <p:cSld>
     <p:spTree>
@@ -1591,32 +1506,17 @@
           <a:lstStyle/>
           <a:p>
             <a:r>
-              <a:t>The answers are hidden. Ask, then click.</a:t>
-            </a:r>
-          </a:p>
-          <a:p>
-            <a:r>
-              <a:t>1. an email address</a:t>
-            </a:r>
-          </a:p>
-          <a:p>
-            <a:r>
-              <a:t>2. a checkbox</a:t>
-            </a:r>
-          </a:p>
-          <a:p>
-            <a:r>
-              <a:t>3. capital</a:t>
-            </a:r>
-          </a:p>
-          <a:p>
-            <a:r>
-              <a:t>Lesson plan: Step 2: Check the Meaning.</a:t>
-            </a:r>
-          </a:p>
-          <a:p>
-            <a:r>
-              <a:t>Pictures: Twemoji graphics by Twitter, Inc. and other contributors (https://github.com/jdecked/twemoji), CC BY 4.0 (https://creativecommons.org/licenses/by/4.0/); resized and combined, with signs and labels (images/CREDITS.md).</a:t>
+              <a:t>Grammar Box 1: a negative tag. Each click shows the answer side.</a:t>
+            </a:r>
+          </a:p>
+          <a:p>
+            <a:r>
+              <a:t>Lesson plan: Step 4; Grammar Box 1.</a:t>
+            </a:r>
+          </a:p>
+          <a:p>
+            <a:r>
+              <a:t>Picture: Twemoji graphics by Twitter, Inc. and other contributors (https://github.com/jdecked/twemoji), CC BY 4.0 (https://creativecommons.org/licenses/by/4.0/); resized and combined, with signs and labels (images/CREDITS.md).</a:t>
             </a:r>
           </a:p>
         </p:txBody>
@@ -1641,7 +1541,7 @@
 </p:notes>
 </file>
 
-<file path=ppt/notesSlides/notesSlide24.xml><?xml version="1.0" encoding="utf-8"?>
+<file path=ppt/notesSlides/notesSlide40.xml><?xml version="1.0" encoding="utf-8"?>
 <p:notes xmlns:a="http://schemas.openxmlformats.org/drawingml/2006/main" xmlns:p="http://schemas.openxmlformats.org/presentationml/2006/main" xmlns:r="http://schemas.openxmlformats.org/officeDocument/2006/relationships">
   <p:cSld>
     <p:spTree>
@@ -1686,17 +1586,17 @@
           <a:lstStyle/>
           <a:p>
             <a:r>
-              <a:t>A points to a picture. B names it and uses it in one sentence. Then switch.</a:t>
-            </a:r>
-          </a:p>
-          <a:p>
-            <a:r>
-              <a:t>Lesson plan: Step 2; New Words page; Partner game.</a:t>
-            </a:r>
-          </a:p>
-          <a:p>
-            <a:r>
-              <a:t>Pictures: Twemoji graphics by Twitter, Inc. and other contributors (https://github.com/jdecked/twemoji), CC BY 4.0 (https://creativecommons.org/licenses/by/4.0/); resized and combined, with signs and labels (images/CREDITS.md).</a:t>
+              <a:t>Grammar Box 2: a positive tag. Each click shows the answer side.</a:t>
+            </a:r>
+          </a:p>
+          <a:p>
+            <a:r>
+              <a:t>Lesson plan: Step 4; Grammar Box 2.</a:t>
+            </a:r>
+          </a:p>
+          <a:p>
+            <a:r>
+              <a:t>Picture: Twemoji graphics by Twitter, Inc. and other contributors (https://github.com/jdecked/twemoji), CC BY 4.0 (https://creativecommons.org/licenses/by/4.0/); resized and combined, with signs and labels (images/CREDITS.md).</a:t>
             </a:r>
           </a:p>
         </p:txBody>
@@ -1721,7 +1621,7 @@
 </p:notes>
 </file>
 
-<file path=ppt/notesSlides/notesSlide25.xml><?xml version="1.0" encoding="utf-8"?>
+<file path=ppt/notesSlides/notesSlide41.xml><?xml version="1.0" encoding="utf-8"?>
 <p:notes xmlns:a="http://schemas.openxmlformats.org/drawingml/2006/main" xmlns:p="http://schemas.openxmlformats.org/presentationml/2006/main" xmlns:r="http://schemas.openxmlformats.org/officeDocument/2006/relationships">
   <p:cSld>
     <p:spTree>
@@ -1766,22 +1666,17 @@
           <a:lstStyle/>
           <a:p>
             <a:r>
-              <a:t>Step 2 · 6:06–6:12 · New Words.</a:t>
-            </a:r>
-          </a:p>
-          <a:p>
-            <a:r>
-              <a:t>Point to each picture. Learners repeat. ★ = most important.</a:t>
-            </a:r>
-          </a:p>
-          <a:p>
-            <a:r>
-              <a:t>Lesson plan: Step 2; New Words page.</a:t>
-            </a:r>
-          </a:p>
-          <a:p>
-            <a:r>
-              <a:t>Pictures: Twemoji graphics by Twitter, Inc. and other contributors (https://github.com/jdecked/twemoji), CC BY 4.0 (https://creativecommons.org/licenses/by/4.0/); resized and combined, with signs and labels (images/CREDITS.md).</a:t>
+              <a:t>Grammar Box 3: do, does, or did. Each click shows the answer side.</a:t>
+            </a:r>
+          </a:p>
+          <a:p>
+            <a:r>
+              <a:t>Lesson plan: Step 4; Grammar Box 3.</a:t>
+            </a:r>
+          </a:p>
+          <a:p>
+            <a:r>
+              <a:t>Picture: Twemoji graphics by Twitter, Inc. and other contributors (https://github.com/jdecked/twemoji), CC BY 4.0 (https://creativecommons.org/licenses/by/4.0/); resized and combined, with signs and labels (images/CREDITS.md).</a:t>
             </a:r>
           </a:p>
         </p:txBody>
@@ -1806,7 +1701,7 @@
 </p:notes>
 </file>
 
-<file path=ppt/notesSlides/notesSlide27.xml><?xml version="1.0" encoding="utf-8"?>
+<file path=ppt/notesSlides/notesSlide42.xml><?xml version="1.0" encoding="utf-8"?>
 <p:notes xmlns:a="http://schemas.openxmlformats.org/drawingml/2006/main" xmlns:p="http://schemas.openxmlformats.org/presentationml/2006/main" xmlns:r="http://schemas.openxmlformats.org/officeDocument/2006/relationships">
   <p:cSld>
     <p:spTree>
@@ -1851,22 +1746,12 @@
           <a:lstStyle/>
           <a:p>
             <a:r>
-              <a:t>Welcome learners as they arrive.</a:t>
-            </a:r>
-          </a:p>
-          <a:p>
-            <a:r>
-              <a:t>Read the three lines under Today you will.</a:t>
-            </a:r>
-          </a:p>
-          <a:p>
-            <a:r>
-              <a:t>Do not collect real Social Security numbers, immigration papers, bank numbers, or medical record numbers.</a:t>
-            </a:r>
-          </a:p>
-          <a:p>
-            <a:r>
-              <a:t>Lesson plan: Topic; At a glance: Objectives.</a:t>
+              <a:t>Grammar Box 4: correct a detail. Each click shows the answer side.</a:t>
+            </a:r>
+          </a:p>
+          <a:p>
+            <a:r>
+              <a:t>Lesson plan: Step 4; Grammar Box 4.</a:t>
             </a:r>
           </a:p>
           <a:p>
@@ -1896,7 +1781,7 @@
 </p:notes>
 </file>
 
-<file path=ppt/notesSlides/notesSlide28.xml><?xml version="1.0" encoding="utf-8"?>
+<file path=ppt/notesSlides/notesSlide43.xml><?xml version="1.0" encoding="utf-8"?>
 <p:notes xmlns:a="http://schemas.openxmlformats.org/drawingml/2006/main" xmlns:p="http://schemas.openxmlformats.org/presentationml/2006/main" xmlns:r="http://schemas.openxmlformats.org/officeDocument/2006/relationships">
   <p:cSld>
     <p:spTree>
@@ -1941,12 +1826,12 @@
           <a:lstStyle/>
           <a:p>
             <a:r>
-              <a:t>Read each goal slowly. Learners repeat.</a:t>
-            </a:r>
-          </a:p>
-          <a:p>
-            <a:r>
-              <a:t>Lesson plan: At a glance: Objectives.</a:t>
+              <a:t>Click to show each answer: 1 didn't you • 2 isn't it • 3 is she • 4 don't you • 5 doesn't it • 6 didn't she</a:t>
+            </a:r>
+          </a:p>
+          <a:p>
+            <a:r>
+              <a:t>Lesson plan: Step 4; Grammar Practice A; Answer key.</a:t>
             </a:r>
           </a:p>
         </p:txBody>
@@ -1971,7 +1856,7 @@
 </p:notes>
 </file>
 
-<file path=ppt/notesSlides/notesSlide29.xml><?xml version="1.0" encoding="utf-8"?>
+<file path=ppt/notesSlides/notesSlide44.xml><?xml version="1.0" encoding="utf-8"?>
 <p:notes xmlns:a="http://schemas.openxmlformats.org/drawingml/2006/main" xmlns:p="http://schemas.openxmlformats.org/presentationml/2006/main" xmlns:r="http://schemas.openxmlformats.org/officeDocument/2006/relationships">
   <p:cSld>
     <p:spTree>
@@ -2016,22 +1901,12 @@
           <a:lstStyle/>
           <a:p>
             <a:r>
-              <a:t>Step 1 · 6:00–6:06 · Opening Talk.</a:t>
-            </a:r>
-          </a:p>
-          <a:p>
-            <a:r>
-              <a:t>Work with a partner.</a:t>
-            </a:r>
-          </a:p>
-          <a:p>
-            <a:r>
-              <a:t>Lesson plan: Step 1; Opening Talk page.</a:t>
-            </a:r>
-          </a:p>
-          <a:p>
-            <a:r>
-              <a:t>Picture: Twemoji graphics by Twitter, Inc. and other contributors (https://github.com/jdecked/twemoji), CC BY 4.0 (https://creativecommons.org/licenses/by/4.0/); resized and combined, with signs and labels (images/CREDITS.md).</a:t>
+              <a:t>Click to circle each answer: 1 Yes, I did • 2 isn't it • 3 is she • 4 didn't you • 5 isn't it • 6 No, I didn't</a:t>
+            </a:r>
+          </a:p>
+          <a:p>
+            <a:r>
+              <a:t>Lesson plan: Step 4; Grammar Practice B; Answer key.</a:t>
             </a:r>
           </a:p>
         </p:txBody>
@@ -2056,7 +1931,7 @@
 </p:notes>
 </file>
 
-<file path=ppt/notesSlides/notesSlide3.xml><?xml version="1.0" encoding="utf-8"?>
+<file path=ppt/notesSlides/notesSlide45.xml><?xml version="1.0" encoding="utf-8"?>
 <p:notes xmlns:a="http://schemas.openxmlformats.org/drawingml/2006/main" xmlns:p="http://schemas.openxmlformats.org/presentationml/2006/main" xmlns:r="http://schemas.openxmlformats.org/officeDocument/2006/relationships">
   <p:cSld>
     <p:spTree>
@@ -2101,17 +1976,17 @@
           <a:lstStyle/>
           <a:p>
             <a:r>
-              <a:t>Step 6 · 7:18–7:25 · Read &amp; Write.</a:t>
-            </a:r>
-          </a:p>
-          <a:p>
-            <a:r>
-              <a:t>Click to show each answer: 1 C-42 • 2 Tuesday at 6:00 • 3 Room C • 4 Room A • 5 The room</a:t>
-            </a:r>
-          </a:p>
-          <a:p>
-            <a:r>
-              <a:t>Lesson plan: Step 6; Read &amp; Write page; Answer key.</a:t>
+              <a:t>Read Don't say, then Say. Learners try first. Then click.</a:t>
+            </a:r>
+          </a:p>
+          <a:p>
+            <a:r>
+              <a:t>Lesson plan: Grammar: Common mistakes.</a:t>
+            </a:r>
+          </a:p>
+          <a:p>
+            <a:r>
+              <a:t>Picture: Twemoji graphics by Twitter, Inc. and other contributors (https://github.com/jdecked/twemoji), CC BY 4.0 (https://creativecommons.org/licenses/by/4.0/); resized and combined, with signs and labels (images/CREDITS.md).</a:t>
             </a:r>
           </a:p>
         </p:txBody>
@@ -2136,7 +2011,7 @@
 </p:notes>
 </file>
 
-<file path=ppt/notesSlides/notesSlide30.xml><?xml version="1.0" encoding="utf-8"?>
+<file path=ppt/notesSlides/notesSlide46.xml><?xml version="1.0" encoding="utf-8"?>
 <p:notes xmlns:a="http://schemas.openxmlformats.org/drawingml/2006/main" xmlns:p="http://schemas.openxmlformats.org/presentationml/2006/main" xmlns:r="http://schemas.openxmlformats.org/officeDocument/2006/relationships">
   <p:cSld>
     <p:spTree>
@@ -2181,17 +2056,22 @@
           <a:lstStyle/>
           <a:p>
             <a:r>
-              <a:t>Each click shows the next card.</a:t>
-            </a:r>
-          </a:p>
-          <a:p>
-            <a:r>
-              <a:t>A asks. B answers. Then switch.</a:t>
-            </a:r>
-          </a:p>
-          <a:p>
-            <a:r>
-              <a:t>Lesson plan: Step 1; Opening Talk page.</a:t>
+              <a:t>Model: It's Tuesday, isn't it? Actually, it's Wednesday. | Detail | Copy A | Copy B | |---|---|---| | Day | Tuesday | Wednesday | | Time | 6:00 | 6:00 | | Room | C | C | | Email | leah@mail.example | leah@mail.example |</a:t>
+            </a:r>
+          </a:p>
+          <a:p>
+            <a:r>
+              <a:t>Break · 6:45–7:00.</a:t>
+            </a:r>
+          </a:p>
+          <a:p>
+            <a:r>
+              <a:t>Lesson plan: Step 4: Pair check.</a:t>
+            </a:r>
+          </a:p>
+          <a:p>
+            <a:r>
+              <a:t>Picture: Twemoji graphics by Twitter, Inc. and other contributors (https://github.com/jdecked/twemoji), CC BY 4.0 (https://creativecommons.org/licenses/by/4.0/); resized and combined, with signs and labels (images/CREDITS.md).</a:t>
             </a:r>
           </a:p>
         </p:txBody>
@@ -2216,7 +2096,7 @@
 </p:notes>
 </file>
 
-<file path=ppt/notesSlides/notesSlide4.xml><?xml version="1.0" encoding="utf-8"?>
+<file path=ppt/notesSlides/notesSlide47.xml><?xml version="1.0" encoding="utf-8"?>
 <p:notes xmlns:a="http://schemas.openxmlformats.org/drawingml/2006/main" xmlns:p="http://schemas.openxmlformats.org/presentationml/2006/main" xmlns:r="http://schemas.openxmlformats.org/officeDocument/2006/relationships">
   <p:cSld>
     <p:spTree>
@@ -2261,7 +2141,7 @@
           <a:lstStyle/>
           <a:p>
             <a:r>
-              <a:t>Round 2.</a:t>
+              <a:t>Round 1.</a:t>
             </a:r>
           </a:p>
           <a:p>
@@ -2296,7 +2176,7 @@
 </p:notes>
 </file>
 
-<file path=ppt/notesSlides/notesSlide5.xml><?xml version="1.0" encoding="utf-8"?>
+<file path=ppt/notesSlides/notesSlide48.xml><?xml version="1.0" encoding="utf-8"?>
 <p:notes xmlns:a="http://schemas.openxmlformats.org/drawingml/2006/main" xmlns:p="http://schemas.openxmlformats.org/presentationml/2006/main" xmlns:r="http://schemas.openxmlformats.org/officeDocument/2006/relationships">
   <p:cSld>
     <p:spTree>
@@ -2341,7 +2221,7 @@
           <a:lstStyle/>
           <a:p>
             <a:r>
-              <a:t>Round 1.</a:t>
+              <a:t>Round 2.</a:t>
             </a:r>
           </a:p>
           <a:p>
@@ -2376,7 +2256,7 @@
 </p:notes>
 </file>
 
-<file path=ppt/notesSlides/notesSlide51.xml><?xml version="1.0" encoding="utf-8"?>
+<file path=ppt/notesSlides/notesSlide49.xml><?xml version="1.0" encoding="utf-8"?>
 <p:notes xmlns:a="http://schemas.openxmlformats.org/drawingml/2006/main" xmlns:p="http://schemas.openxmlformats.org/presentationml/2006/main" xmlns:r="http://schemas.openxmlformats.org/officeDocument/2006/relationships">
   <p:cSld>
     <p:spTree>
@@ -2421,22 +2301,17 @@
           <a:lstStyle/>
           <a:p>
             <a:r>
-              <a:t>Read the three Now you can lines.</a:t>
-            </a:r>
-          </a:p>
-          <a:p>
-            <a:r>
-              <a:t>Homework is about 20–25 minutes. Bring it next week.</a:t>
-            </a:r>
-          </a:p>
-          <a:p>
-            <a:r>
-              <a:t>Lesson plan: At a glance: Objectives; Step 7.</a:t>
-            </a:r>
-          </a:p>
-          <a:p>
-            <a:r>
-              <a:t>Picture: Twemoji graphics by Twitter, Inc. and other contributors (https://github.com/jdecked/twemoji), CC BY 4.0 (https://creativecommons.org/licenses/by/4.0/); resized and combined, with signs and labels (images/CREDITS.md).</a:t>
+              <a:t>Step 6 · 7:18–7:25 · Read &amp; Write.</a:t>
+            </a:r>
+          </a:p>
+          <a:p>
+            <a:r>
+              <a:t>Click to show each answer: 1 C-42 • 2 Tuesday at 6:00 • 3 Room C • 4 Room A • 5 The room</a:t>
+            </a:r>
+          </a:p>
+          <a:p>
+            <a:r>
+              <a:t>Lesson plan: Step 6; Read &amp; Write page; Answer key.</a:t>
             </a:r>
           </a:p>
         </p:txBody>
@@ -2461,7 +2336,7 @@
 </p:notes>
 </file>
 
-<file path=ppt/notesSlides/notesSlide6.xml><?xml version="1.0" encoding="utf-8"?>
+<file path=ppt/notesSlides/notesSlide50.xml><?xml version="1.0" encoding="utf-8"?>
 <p:notes xmlns:a="http://schemas.openxmlformats.org/drawingml/2006/main" xmlns:p="http://schemas.openxmlformats.org/presentationml/2006/main" xmlns:r="http://schemas.openxmlformats.org/officeDocument/2006/relationships">
   <p:cSld>
     <p:spTree>
@@ -2506,17 +2381,17 @@
           <a:lstStyle/>
           <a:p>
             <a:r>
-              <a:t>Model: It's Tuesday, isn't it? Actually, it's Wednesday. | Detail | Copy A | Copy B | |---|---|---| | Day | Tuesday | Wednesday | | Time | 6:00 | 6:00 | | Room | C | C | | Email | leah@mail.example | leah@mail.example |</a:t>
-            </a:r>
-          </a:p>
-          <a:p>
-            <a:r>
-              <a:t>Break · 6:45–7:00.</a:t>
-            </a:r>
-          </a:p>
-          <a:p>
-            <a:r>
-              <a:t>Lesson plan: Step 4: Pair check.</a:t>
+              <a:t>Step 7 · 7:25–7:30 · Exit ticket and homework. Never skip the exit ticket.</a:t>
+            </a:r>
+          </a:p>
+          <a:p>
+            <a:r>
+              <a:t>Confirm two details about this class.</a:t>
+            </a:r>
+          </a:p>
+          <a:p>
+            <a:r>
+              <a:t>Lesson plan: Step 7; Exit Ticket page; Homework page.</a:t>
             </a:r>
           </a:p>
           <a:p>
@@ -2546,7 +2421,7 @@
 </p:notes>
 </file>
 
-<file path=ppt/notesSlides/notesSlide7.xml><?xml version="1.0" encoding="utf-8"?>
+<file path=ppt/notesSlides/notesSlide52.xml><?xml version="1.0" encoding="utf-8"?>
 <p:notes xmlns:a="http://schemas.openxmlformats.org/drawingml/2006/main" xmlns:p="http://schemas.openxmlformats.org/presentationml/2006/main" xmlns:r="http://schemas.openxmlformats.org/officeDocument/2006/relationships">
   <p:cSld>
     <p:spTree>
@@ -2591,17 +2466,27 @@
           <a:lstStyle/>
           <a:p>
             <a:r>
-              <a:t>Read Don't say, then Say. Learners try first. Then click.</a:t>
-            </a:r>
-          </a:p>
-          <a:p>
-            <a:r>
-              <a:t>Lesson plan: Grammar: Common mistakes.</a:t>
-            </a:r>
-          </a:p>
-          <a:p>
-            <a:r>
-              <a:t>Picture: Twemoji graphics by Twitter, Inc. and other contributors (https://github.com/jdecked/twemoji), CC BY 4.0 (https://creativecommons.org/licenses/by/4.0/); resized and combined, with signs and labels (images/CREDITS.md).</a:t>
+              <a:t>Credits. You don't need to read this slide in class.</a:t>
+            </a:r>
+          </a:p>
+          <a:p>
+            <a:r>
+              <a:t>Pictures: Twemoji graphics by Twitter, Inc. and other contributors, CC BY 4.0; the file-by-file list is in images/CREDITS.md.</a:t>
+            </a:r>
+          </a:p>
+          <a:p>
+            <a:r>
+              <a:t>Audio: synthetic voices, computer-generated (Chatterbox TTS cloned from Kokoro-82M reference clips). No recordings of real people. The names and the story are invented.</a:t>
+            </a:r>
+          </a:p>
+          <a:p>
+            <a:r>
+              <a:t>Course materials: © 2026 the authors, licensed under CC BY-NC-SA 4.0 (https://creativecommons.org/licenses/by-nc-sa/4.0/).</a:t>
+            </a:r>
+          </a:p>
+          <a:p>
+            <a:r>
+              <a:t>Lesson plan: Picture Credits. Picture list: images/CREDITS.md.</a:t>
             </a:r>
           </a:p>
         </p:txBody>
@@ -2626,7 +2511,7 @@
 </p:notes>
 </file>
 
-<file path=ppt/notesSlides/notesSlide9.xml><?xml version="1.0" encoding="utf-8"?>
+<file path=ppt/notesSlides/notesSlide8.xml><?xml version="1.0" encoding="utf-8"?>
 <p:notes xmlns:a="http://schemas.openxmlformats.org/drawingml/2006/main" xmlns:p="http://schemas.openxmlformats.org/presentationml/2006/main" xmlns:r="http://schemas.openxmlformats.org/officeDocument/2006/relationships">
   <p:cSld>
     <p:spTree>
@@ -2671,12 +2556,22 @@
           <a:lstStyle/>
           <a:p>
             <a:r>
-              <a:t>Click to circle each answer: 1 Yes, I did • 2 isn't it • 3 is she • 4 didn't you • 5 isn't it • 6 No, I didn't</a:t>
-            </a:r>
-          </a:p>
-          <a:p>
-            <a:r>
-              <a:t>Lesson plan: Step 4; Grammar Practice B; Answer key.</a:t>
+              <a:t>Read the three Now you can lines.</a:t>
+            </a:r>
+          </a:p>
+          <a:p>
+            <a:r>
+              <a:t>Homework is about 20–25 minutes. Bring it next week.</a:t>
+            </a:r>
+          </a:p>
+          <a:p>
+            <a:r>
+              <a:t>Lesson plan: At a glance: Objectives; Step 7.</a:t>
+            </a:r>
+          </a:p>
+          <a:p>
+            <a:r>
+              <a:t>Picture: Twemoji graphics by Twitter, Inc. and other contributors (https://github.com/jdecked/twemoji), CC BY 4.0 (https://creativecommons.org/licenses/by/4.0/); resized and combined, with signs and labels (images/CREDITS.md).</a:t>
             </a:r>
           </a:p>
         </p:txBody>
@@ -11004,7 +10899,7 @@
                 <a:ea typeface="Lexend Deca" pitchFamily="34" charset="-122"/>
                 <a:cs typeface="Lexend Deca" pitchFamily="34" charset="-120"/>
               </a:rPr>
-              <a:t>Audio (about 2:10): coming soon.</a:t>
+              <a:t>Audio: about 1:30. It plays once.</a:t>
             </a:r>
             <a:endParaRPr lang="en-US" sz="2200" dirty="0"/>
           </a:p>
@@ -29133,7 +29028,7 @@
                 <a:ea typeface="Lexend Deca" pitchFamily="34" charset="-122"/>
                 <a:cs typeface="Lexend Deca" pitchFamily="34" charset="-120"/>
               </a:rPr>
-              <a:t>Audio (coming soon): synthetic voices made with Chatterbox TTS (MIT License), cloned from short synthetic reference clips made with Kokoro-82M (Apache License 2.0). No recordings of real people. Each file will carry an inaudible Perth watermark marking it as AI-generated. Font: Lexend Deca (OFL 1.1).</a:t>
+              <a:t>Audio: synthetic voices made with Chatterbox TTS (MIT License), cloned from short synthetic reference clips made with Kokoro-82M (Apache License 2.0). No recordings of real people were used. Each file carries an inaudible Perth watermark marking it as AI-generated. Font: Lexend Deca (OFL 1.1).</a:t>
             </a:r>
             <a:endParaRPr lang="en-US" sz="1350" dirty="0" b="0"/>
           </a:p>

</xml_diff>